<commit_message>
docs: actualizar presentacion con los resultados finales en test
</commit_message>
<xml_diff>
--- a/reports/presentacion/ASL_resultados.pptx
+++ b/reports/presentacion/ASL_resultados.pptx
@@ -5506,7 +5506,7 @@
                 <a:ea typeface="Arial"/>
                 <a:cs typeface="Arial"/>
               </a:rPr>
-              <a:t>Pendiente externo: pesos finales de M2/M3 y métricas finales de test.</a:t>
+              <a:t>Límites: los espacios (27 % de error en M1) y M3 sin converger en 15 épocas.</a:t>
             </a:r>
           </a:p>
         </p:txBody>
@@ -5572,7 +5572,7 @@
                 <a:ea typeface="Arial"/>
                 <a:cs typeface="Arial"/>
               </a:rPr>
-              <a:t>La app queda preparada para integrar los tres modelos.</a:t>
+              <a:t>Siguiente: aumento de datos y modelo de lenguaje.</a:t>
             </a:r>
           </a:p>
         </p:txBody>
@@ -7411,7 +7411,7 @@
                 <a:ea typeface="Arial"/>
                 <a:cs typeface="Arial"/>
               </a:rPr>
-              <a:t>Disponible para la demo: M1.</a:t>
+              <a:t>Disponibles en la demo: M1, M2 y M3.</a:t>
             </a:r>
           </a:p>
           <a:p xmlns:a="http://schemas.openxmlformats.org/drawingml/2006/main">
@@ -7434,7 +7434,7 @@
                 <a:ea typeface="Arial"/>
                 <a:cs typeface="Arial"/>
               </a:rPr>
-              <a:t>M2 y M3 se activan al incorporar sus checkpoints finales.</a:t>
+              <a:t>Mejor en prueba: M1. Más eficiente: M2.</a:t>
             </a:r>
           </a:p>
         </p:txBody>
@@ -7529,7 +7529,7 @@
                 <a:ea typeface="Arial"/>
                 <a:cs typeface="Arial"/>
               </a:rPr>
-              <a:t>Resultados disponibles de BiGRU</a:t>
+              <a:t>Resultados en prueba: M1 BiGRU es el mejor</a:t>
             </a:r>
           </a:p>
         </p:txBody>
@@ -7727,7 +7727,7 @@
                 <a:ea typeface="Arial"/>
                 <a:cs typeface="Arial"/>
               </a:rPr>
-              <a:t>0,2435</a:t>
+              <a:t>0,217</a:t>
             </a:r>
           </a:p>
         </p:txBody>
@@ -7793,7 +7793,7 @@
                 <a:ea typeface="Arial"/>
                 <a:cs typeface="Arial"/>
               </a:rPr>
-              <a:t>Distancia de edición normalizada</a:t>
+              <a:t>Distancia de edición normalizada · M1</a:t>
             </a:r>
           </a:p>
         </p:txBody>
@@ -7859,7 +7859,7 @@
                 <a:ea typeface="Arial"/>
                 <a:cs typeface="Arial"/>
               </a:rPr>
-              <a:t>CER  0,2425</a:t>
+              <a:t>CER  0,216</a:t>
             </a:r>
           </a:p>
           <a:p xmlns:a="http://schemas.openxmlformats.org/drawingml/2006/main">
@@ -7882,7 +7882,7 @@
                 <a:ea typeface="Arial"/>
                 <a:cs typeface="Arial"/>
               </a:rPr>
-              <a:t>Frase exacta  13,12 %</a:t>
+              <a:t>Frase exacta  10,9 %</a:t>
             </a:r>
           </a:p>
           <a:p xmlns:a="http://schemas.openxmlformats.org/drawingml/2006/main">
@@ -7905,7 +7905,7 @@
                 <a:ea typeface="Arial"/>
                 <a:cs typeface="Arial"/>
               </a:rPr>
-              <a:t>473 405 parámetros</a:t>
+              <a:t>1,67 M parámetros</a:t>
             </a:r>
           </a:p>
         </p:txBody>
@@ -7971,7 +7971,7 @@
                 <a:ea typeface="Arial"/>
                 <a:cs typeface="Arial"/>
               </a:rPr>
-              <a:t>3 857 secuencias de validación · checkpoint de la época 8</a:t>
+              <a:t>4 181 frases de prueba · 10 participantes no vistos</a:t>
             </a:r>
           </a:p>
         </p:txBody>
@@ -8037,7 +8037,7 @@
                 <a:ea typeface="Arial"/>
                 <a:cs typeface="Arial"/>
               </a:rPr>
-              <a:t>La evaluación final en test aún no está registrada en los artefactos locales.</a:t>
+              <a:t>M2 TCN: 0,247 con la mitad del tiempo · M3 Transformer: 0,256, aún mejorando</a:t>
             </a:r>
           </a:p>
         </p:txBody>

</xml_diff>